<commit_message>
feat: Add Docker healthchecks, API circuit breakers, SQL whitelist, and CI pipeline
</commit_message>
<xml_diff>
--- a/docs/ai_quant_codebase_classroom.pptx
+++ b/docs/ai_quant_codebase_classroom.pptx
@@ -16,11 +16,8 @@
     <p:sldId id="264" r:id="rId15"/>
     <p:sldId id="265" r:id="rId16"/>
     <p:sldId id="266" r:id="rId17"/>
-    <p:sldId id="267" r:id="rId18"/>
-    <p:sldId id="268" r:id="rId19"/>
-    <p:sldId id="269" r:id="rId20"/>
   </p:sldIdLst>
-  <p:sldSz cx="9144000" cy="6858000" type="screen4x3"/>
+  <p:sldSz cx="12191695" cy="6858000" type="screen4x3"/>
   <p:notesSz cx="6858000" cy="9144000"/>
   <p:defaultTextStyle>
     <a:defPPr>
@@ -3117,11 +3114,6 @@
           <a:lstStyle/>
           <a:p>
             <a:r>
-              <a:rPr sz="3400">
-                <a:solidFill>
-                  <a:srgbClr val="0B2545"/>
-                </a:solidFill>
-              </a:rPr>
               <a:t>AI Quant Investment Engine</a:t>
             </a:r>
           </a:p>
@@ -3143,7 +3135,7 @@
           <a:lstStyle/>
           <a:p>
             <a:r>
-              <a:t>Big Data Technology Class Deck | Generated 2026-02-26 20:01</a:t>
+              <a:t>Classroom Deck (updated for latest codebase)</a:t>
             </a:r>
           </a:p>
         </p:txBody>
@@ -3182,12 +3174,7 @@
           <a:lstStyle/>
           <a:p>
             <a:r>
-              <a:rPr sz="3400">
-                <a:solidFill>
-                  <a:srgbClr val="0B2545"/>
-                </a:solidFill>
-              </a:rPr>
-              <a:t>RSI, ATR, Stochastic</a:t>
+              <a:t>Hands-On Commands</a:t>
             </a:r>
           </a:p>
         </p:txBody>
@@ -3208,34 +3195,34 @@
           <a:lstStyle/>
           <a:p>
             <a:pPr>
-              <a:defRPr sz="2100"/>
+              <a:defRPr sz="1800"/>
             </a:pPr>
             <a:r>
-              <a:t>RSI(14): momentum oscillator from avg gains/losses</a:t>
+              <a:t>docker compose exec airflow-api-server airflow dags trigger ai_quant_daily_pipeline</a:t>
             </a:r>
           </a:p>
           <a:p>
             <a:pPr>
-              <a:defRPr sz="2100"/>
+              <a:defRPr sz="1800"/>
             </a:pPr>
             <a:r>
-              <a:t>ATR(14): average true range from high/low + gap terms</a:t>
+              <a:t>docker compose exec airflow-api-server airflow dags trigger ai_quant_model_validation_weekly</a:t>
             </a:r>
           </a:p>
           <a:p>
             <a:pPr>
-              <a:defRPr sz="2100"/>
+              <a:defRPr sz="1800"/>
             </a:pPr>
             <a:r>
-              <a:t>Stochastic %K/%D: close position within recent 14-day range</a:t>
+              <a:t>docker compose exec airflow-api-server airflow tasks states-for-dag-run ai_quant_model_validation_weekly &lt;run_id&gt;</a:t>
             </a:r>
           </a:p>
           <a:p>
             <a:pPr>
-              <a:defRPr sz="2100"/>
+              <a:defRPr sz="1800"/>
             </a:pPr>
             <a:r>
-              <a:t>Together: momentum + risk + range position context</a:t>
+              <a:t>docker compose exec airflow-api-server python -m src.recommendation.walk_forward_evaluation --source-table silver.nifty50_features_daily --model-type auto</a:t>
             </a:r>
           </a:p>
         </p:txBody>
@@ -3274,12 +3261,7 @@
           <a:lstStyle/>
           <a:p>
             <a:r>
-              <a:rPr sz="3400">
-                <a:solidFill>
-                  <a:srgbClr val="0B2545"/>
-                </a:solidFill>
-              </a:rPr>
-              <a:t>Performance Decisions (Critical)</a:t>
+              <a:t>Takeaways</a:t>
             </a:r>
           </a:p>
         </p:txBody>
@@ -3303,307 +3285,23 @@
               <a:defRPr sz="2100"/>
             </a:pPr>
             <a:r>
-              <a:t>Repartition by symbol before window functions</a:t>
+              <a:t>This codebase now includes both prediction and governance loops.</a:t>
             </a:r>
           </a:p>
           <a:p>
             <a:pPr>
-              <a:defRPr sz="2100"/>
+              <a:defRPr sz="1800"/>
             </a:pPr>
             <a:r>
-              <a:t>Single-pass chained withColumn transforms</a:t>
+              <a:t>Financial formulas are explicit and validated against pandas reference.</a:t>
             </a:r>
           </a:p>
           <a:p>
             <a:pPr>
-              <a:defRPr sz="2100"/>
+              <a:defRPr sz="1800"/>
             </a:pPr>
             <a:r>
-              <a:t>Cache/unpersist around compute_indicators</a:t>
-            </a:r>
-          </a:p>
-          <a:p>
-            <a:pPr>
-              <a:defRPr sz="2100"/>
-            </a:pPr>
-            <a:r>
-              <a:t>coalesce(2) before JDBC write to reduce tiny writes</a:t>
-            </a:r>
-          </a:p>
-        </p:txBody>
-      </p:sp>
-    </p:spTree>
-  </p:cSld>
-  <p:clrMapOvr>
-    <a:masterClrMapping/>
-  </p:clrMapOvr>
-</p:sld>
-</file>
-
-<file path=ppt/slides/slide12.xml><?xml version="1.0" encoding="utf-8"?>
-<p:sld xmlns:a="http://schemas.openxmlformats.org/drawingml/2006/main" xmlns:p="http://schemas.openxmlformats.org/presentationml/2006/main" xmlns:r="http://schemas.openxmlformats.org/officeDocument/2006/relationships">
-  <p:cSld>
-    <p:spTree>
-      <p:nvGrpSpPr>
-        <p:cNvPr id="1" name=""/>
-        <p:cNvGrpSpPr/>
-        <p:nvPr/>
-      </p:nvGrpSpPr>
-      <p:grpSpPr/>
-      <p:sp>
-        <p:nvSpPr>
-          <p:cNvPr id="2" name="Title 1"/>
-          <p:cNvSpPr>
-            <a:spLocks noGrp="1"/>
-          </p:cNvSpPr>
-          <p:nvPr>
-            <p:ph type="title"/>
-          </p:nvPr>
-        </p:nvSpPr>
-        <p:spPr/>
-        <p:txBody>
-          <a:bodyPr/>
-          <a:lstStyle/>
-          <a:p>
-            <a:r>
-              <a:rPr sz="3400">
-                <a:solidFill>
-                  <a:srgbClr val="0B2545"/>
-                </a:solidFill>
-              </a:rPr>
-              <a:t>Quality and Caveats</a:t>
-            </a:r>
-          </a:p>
-        </p:txBody>
-      </p:sp>
-      <p:sp>
-        <p:nvSpPr>
-          <p:cNvPr id="3" name="Content Placeholder 2"/>
-          <p:cNvSpPr>
-            <a:spLocks noGrp="1"/>
-          </p:cNvSpPr>
-          <p:nvPr>
-            <p:ph idx="1"/>
-          </p:nvPr>
-        </p:nvSpPr>
-        <p:spPr/>
-        <p:txBody>
-          <a:bodyPr/>
-          <a:lstStyle/>
-          <a:p>
-            <a:pPr>
-              <a:defRPr sz="2100"/>
-            </a:pPr>
-            <a:r>
-              <a:t>Drop rows where sma_50 is null (warmup maturity)</a:t>
-            </a:r>
-          </a:p>
-          <a:p>
-            <a:pPr>
-              <a:defRPr sz="2100"/>
-            </a:pPr>
-            <a:r>
-              <a:t>ema_20 and MACD are SMA-based approximations in current code</a:t>
-            </a:r>
-          </a:p>
-          <a:p>
-            <a:pPr>
-              <a:defRPr sz="2100"/>
-            </a:pPr>
-            <a:r>
-              <a:t>Need explicit guard for stochastic zero denominator edge case</a:t>
-            </a:r>
-          </a:p>
-          <a:p>
-            <a:pPr>
-              <a:defRPr sz="2100"/>
-            </a:pPr>
-            <a:r>
-              <a:t>Add feature benchmark tests for production confidence</a:t>
-            </a:r>
-          </a:p>
-        </p:txBody>
-      </p:sp>
-    </p:spTree>
-  </p:cSld>
-  <p:clrMapOvr>
-    <a:masterClrMapping/>
-  </p:clrMapOvr>
-</p:sld>
-</file>
-
-<file path=ppt/slides/slide13.xml><?xml version="1.0" encoding="utf-8"?>
-<p:sld xmlns:a="http://schemas.openxmlformats.org/drawingml/2006/main" xmlns:p="http://schemas.openxmlformats.org/presentationml/2006/main" xmlns:r="http://schemas.openxmlformats.org/officeDocument/2006/relationships">
-  <p:cSld>
-    <p:spTree>
-      <p:nvGrpSpPr>
-        <p:cNvPr id="1" name=""/>
-        <p:cNvGrpSpPr/>
-        <p:nvPr/>
-      </p:nvGrpSpPr>
-      <p:grpSpPr/>
-      <p:sp>
-        <p:nvSpPr>
-          <p:cNvPr id="2" name="Title 1"/>
-          <p:cNvSpPr>
-            <a:spLocks noGrp="1"/>
-          </p:cNvSpPr>
-          <p:nvPr>
-            <p:ph type="title"/>
-          </p:nvPr>
-        </p:nvSpPr>
-        <p:spPr/>
-        <p:txBody>
-          <a:bodyPr/>
-          <a:lstStyle/>
-          <a:p>
-            <a:r>
-              <a:rPr sz="3400">
-                <a:solidFill>
-                  <a:srgbClr val="0B2545"/>
-                </a:solidFill>
-              </a:rPr>
-              <a:t>Student Lab Tasks</a:t>
-            </a:r>
-          </a:p>
-        </p:txBody>
-      </p:sp>
-      <p:sp>
-        <p:nvSpPr>
-          <p:cNvPr id="3" name="Content Placeholder 2"/>
-          <p:cNvSpPr>
-            <a:spLocks noGrp="1"/>
-          </p:cNvSpPr>
-          <p:nvPr>
-            <p:ph idx="1"/>
-          </p:nvPr>
-        </p:nvSpPr>
-        <p:spPr/>
-        <p:txBody>
-          <a:bodyPr/>
-          <a:lstStyle/>
-          <a:p>
-            <a:pPr>
-              <a:defRPr sz="2100"/>
-            </a:pPr>
-            <a:r>
-              <a:t>Implement true EMA_20 and compare model behavior</a:t>
-            </a:r>
-          </a:p>
-          <a:p>
-            <a:pPr>
-              <a:defRPr sz="2100"/>
-            </a:pPr>
-            <a:r>
-              <a:t>Harden stochastic denominator edge handling</a:t>
-            </a:r>
-          </a:p>
-          <a:p>
-            <a:pPr>
-              <a:defRPr sz="2100"/>
-            </a:pPr>
-            <a:r>
-              <a:t>Add unit tests with hand-calculated vectors</a:t>
-            </a:r>
-          </a:p>
-          <a:p>
-            <a:pPr>
-              <a:defRPr sz="2100"/>
-            </a:pPr>
-            <a:r>
-              <a:t>Benchmark different partition policies on large symbol sets</a:t>
-            </a:r>
-          </a:p>
-        </p:txBody>
-      </p:sp>
-    </p:spTree>
-  </p:cSld>
-  <p:clrMapOvr>
-    <a:masterClrMapping/>
-  </p:clrMapOvr>
-</p:sld>
-</file>
-
-<file path=ppt/slides/slide14.xml><?xml version="1.0" encoding="utf-8"?>
-<p:sld xmlns:a="http://schemas.openxmlformats.org/drawingml/2006/main" xmlns:p="http://schemas.openxmlformats.org/presentationml/2006/main" xmlns:r="http://schemas.openxmlformats.org/officeDocument/2006/relationships">
-  <p:cSld>
-    <p:spTree>
-      <p:nvGrpSpPr>
-        <p:cNvPr id="1" name=""/>
-        <p:cNvGrpSpPr/>
-        <p:nvPr/>
-      </p:nvGrpSpPr>
-      <p:grpSpPr/>
-      <p:sp>
-        <p:nvSpPr>
-          <p:cNvPr id="2" name="Title 1"/>
-          <p:cNvSpPr>
-            <a:spLocks noGrp="1"/>
-          </p:cNvSpPr>
-          <p:nvPr>
-            <p:ph type="title"/>
-          </p:nvPr>
-        </p:nvSpPr>
-        <p:spPr/>
-        <p:txBody>
-          <a:bodyPr/>
-          <a:lstStyle/>
-          <a:p>
-            <a:r>
-              <a:rPr sz="3400">
-                <a:solidFill>
-                  <a:srgbClr val="0B2545"/>
-                </a:solidFill>
-              </a:rPr>
-              <a:t>Takeaways</a:t>
-            </a:r>
-          </a:p>
-        </p:txBody>
-      </p:sp>
-      <p:sp>
-        <p:nvSpPr>
-          <p:cNvPr id="3" name="Content Placeholder 2"/>
-          <p:cNvSpPr>
-            <a:spLocks noGrp="1"/>
-          </p:cNvSpPr>
-          <p:nvPr>
-            <p:ph idx="1"/>
-          </p:nvPr>
-        </p:nvSpPr>
-        <p:spPr/>
-        <p:txBody>
-          <a:bodyPr/>
-          <a:lstStyle/>
-          <a:p>
-            <a:pPr>
-              <a:defRPr sz="2100"/>
-            </a:pPr>
-            <a:r>
-              <a:t>Silver layer is the mathematical backbone of the product</a:t>
-            </a:r>
-          </a:p>
-          <a:p>
-            <a:pPr>
-              <a:defRPr sz="2100"/>
-            </a:pPr>
-            <a:r>
-              <a:t>Correctness + scalability decisions in ETL determine downstream quality</a:t>
-            </a:r>
-          </a:p>
-          <a:p>
-            <a:pPr>
-              <a:defRPr sz="2100"/>
-            </a:pPr>
-            <a:r>
-              <a:t>Big data engineering is about both formulas and execution strategy</a:t>
-            </a:r>
-          </a:p>
-          <a:p>
-            <a:pPr>
-              <a:defRPr sz="2100"/>
-            </a:pPr>
-            <a:r>
-              <a:t>Great analytics products combine model output with operational trust</a:t>
+              <a:t>The local-first architecture is viable on CPU with staged DAG execution.</a:t>
             </a:r>
           </a:p>
         </p:txBody>
@@ -3642,60 +3340,348 @@
           <a:lstStyle/>
           <a:p>
             <a:r>
-              <a:rPr sz="3400">
-                <a:solidFill>
-                  <a:srgbClr val="0B2545"/>
-                </a:solidFill>
-              </a:rPr>
-              <a:t>Learning Objectives</a:t>
-            </a:r>
-          </a:p>
-        </p:txBody>
-      </p:sp>
-      <p:sp>
-        <p:nvSpPr>
-          <p:cNvPr id="3" name="Content Placeholder 2"/>
-          <p:cNvSpPr>
-            <a:spLocks noGrp="1"/>
-          </p:cNvSpPr>
-          <p:nvPr>
-            <p:ph idx="1"/>
-          </p:nvPr>
-        </p:nvSpPr>
-        <p:spPr/>
-        <p:txBody>
-          <a:bodyPr/>
-          <a:lstStyle/>
-          <a:p>
-            <a:pPr>
-              <a:defRPr sz="2100"/>
-            </a:pPr>
-            <a:r>
-              <a:t>Understand end-to-end analytics architecture in a real product</a:t>
-            </a:r>
-          </a:p>
-          <a:p>
-            <a:pPr>
-              <a:defRPr sz="2100"/>
-            </a:pPr>
-            <a:r>
-              <a:t>Trace Airflow DAG from ingestion to distribution</a:t>
-            </a:r>
-          </a:p>
-          <a:p>
-            <a:pPr>
-              <a:defRPr sz="2100"/>
-            </a:pPr>
-            <a:r>
-              <a:t>Master design and performance choices in pyspark_etl.py</a:t>
-            </a:r>
-          </a:p>
-          <a:p>
-            <a:pPr>
-              <a:defRPr sz="2100"/>
-            </a:pPr>
-            <a:r>
-              <a:t>Interpret silver-layer financial indicators with examples</a:t>
+              <a:t>Pipeline Architecture</a:t>
+            </a:r>
+          </a:p>
+        </p:txBody>
+      </p:sp>
+      <p:sp>
+        <p:nvSpPr>
+          <p:cNvPr id="3" name="Rounded Rectangle 2"/>
+          <p:cNvSpPr/>
+          <p:nvPr/>
+        </p:nvSpPr>
+        <p:spPr>
+          <a:xfrm>
+            <a:off x="640080" y="1554480"/>
+            <a:ext cx="2194560" cy="822960"/>
+          </a:xfrm>
+          <a:prstGeom prst="roundRect">
+            <a:avLst/>
+          </a:prstGeom>
+          <a:solidFill>
+            <a:srgbClr val="DFEAF9"/>
+          </a:solidFill>
+        </p:spPr>
+        <p:style>
+          <a:lnRef idx="1">
+            <a:schemeClr val="accent1"/>
+          </a:lnRef>
+          <a:fillRef idx="3">
+            <a:schemeClr val="accent1"/>
+          </a:fillRef>
+          <a:effectRef idx="2">
+            <a:schemeClr val="accent1"/>
+          </a:effectRef>
+          <a:fontRef idx="minor">
+            <a:schemeClr val="lt1"/>
+          </a:fontRef>
+        </p:style>
+        <p:txBody>
+          <a:bodyPr rtlCol="0" anchor="ctr"/>
+          <a:lstStyle/>
+          <a:p>
+            <a:r>
+              <a:t>Bronze</a:t>
+            </a:r>
+          </a:p>
+          <a:p>
+            <a:r>
+              <a:t>Raw Data</a:t>
+            </a:r>
+          </a:p>
+        </p:txBody>
+      </p:sp>
+      <p:sp>
+        <p:nvSpPr>
+          <p:cNvPr id="4" name="Rounded Rectangle 3"/>
+          <p:cNvSpPr/>
+          <p:nvPr/>
+        </p:nvSpPr>
+        <p:spPr>
+          <a:xfrm>
+            <a:off x="3474720" y="1554480"/>
+            <a:ext cx="2377440" cy="822960"/>
+          </a:xfrm>
+          <a:prstGeom prst="roundRect">
+            <a:avLst/>
+          </a:prstGeom>
+          <a:solidFill>
+            <a:srgbClr val="ECF4FF"/>
+          </a:solidFill>
+        </p:spPr>
+        <p:style>
+          <a:lnRef idx="1">
+            <a:schemeClr val="accent1"/>
+          </a:lnRef>
+          <a:fillRef idx="3">
+            <a:schemeClr val="accent1"/>
+          </a:fillRef>
+          <a:effectRef idx="2">
+            <a:schemeClr val="accent1"/>
+          </a:effectRef>
+          <a:fontRef idx="minor">
+            <a:schemeClr val="lt1"/>
+          </a:fontRef>
+        </p:style>
+        <p:txBody>
+          <a:bodyPr rtlCol="0" anchor="ctr"/>
+          <a:lstStyle/>
+          <a:p>
+            <a:r>
+              <a:t>Silver</a:t>
+            </a:r>
+          </a:p>
+          <a:p>
+            <a:r>
+              <a:t>Spark Indicators</a:t>
+            </a:r>
+          </a:p>
+        </p:txBody>
+      </p:sp>
+      <p:sp>
+        <p:nvSpPr>
+          <p:cNvPr id="5" name="Rounded Rectangle 4"/>
+          <p:cNvSpPr/>
+          <p:nvPr/>
+        </p:nvSpPr>
+        <p:spPr>
+          <a:xfrm>
+            <a:off x="6583680" y="1554480"/>
+            <a:ext cx="2377440" cy="822960"/>
+          </a:xfrm>
+          <a:prstGeom prst="roundRect">
+            <a:avLst/>
+          </a:prstGeom>
+          <a:solidFill>
+            <a:srgbClr val="E9F9EF"/>
+          </a:solidFill>
+        </p:spPr>
+        <p:style>
+          <a:lnRef idx="1">
+            <a:schemeClr val="accent1"/>
+          </a:lnRef>
+          <a:fillRef idx="3">
+            <a:schemeClr val="accent1"/>
+          </a:fillRef>
+          <a:effectRef idx="2">
+            <a:schemeClr val="accent1"/>
+          </a:effectRef>
+          <a:fontRef idx="minor">
+            <a:schemeClr val="lt1"/>
+          </a:fontRef>
+        </p:style>
+        <p:txBody>
+          <a:bodyPr rtlCol="0" anchor="ctr"/>
+          <a:lstStyle/>
+          <a:p>
+            <a:r>
+              <a:t>Gold</a:t>
+            </a:r>
+          </a:p>
+          <a:p>
+            <a:r>
+              <a:t>Signals</a:t>
+            </a:r>
+          </a:p>
+        </p:txBody>
+      </p:sp>
+      <p:sp>
+        <p:nvSpPr>
+          <p:cNvPr id="6" name="Rounded Rectangle 5"/>
+          <p:cNvSpPr/>
+          <p:nvPr/>
+        </p:nvSpPr>
+        <p:spPr>
+          <a:xfrm>
+            <a:off x="9418320" y="1554480"/>
+            <a:ext cx="2011680" cy="822960"/>
+          </a:xfrm>
+          <a:prstGeom prst="roundRect">
+            <a:avLst/>
+          </a:prstGeom>
+          <a:solidFill>
+            <a:srgbClr val="FFF4DB"/>
+          </a:solidFill>
+        </p:spPr>
+        <p:style>
+          <a:lnRef idx="1">
+            <a:schemeClr val="accent1"/>
+          </a:lnRef>
+          <a:fillRef idx="3">
+            <a:schemeClr val="accent1"/>
+          </a:fillRef>
+          <a:effectRef idx="2">
+            <a:schemeClr val="accent1"/>
+          </a:effectRef>
+          <a:fontRef idx="minor">
+            <a:schemeClr val="lt1"/>
+          </a:fontRef>
+        </p:style>
+        <p:txBody>
+          <a:bodyPr rtlCol="0" anchor="ctr"/>
+          <a:lstStyle/>
+          <a:p>
+            <a:r>
+              <a:t>Email + API</a:t>
+            </a:r>
+          </a:p>
+        </p:txBody>
+      </p:sp>
+      <p:sp>
+        <p:nvSpPr>
+          <p:cNvPr id="7" name="Right Arrow 6"/>
+          <p:cNvSpPr/>
+          <p:nvPr/>
+        </p:nvSpPr>
+        <p:spPr>
+          <a:xfrm>
+            <a:off x="2743200" y="1783080"/>
+            <a:ext cx="640080" cy="320040"/>
+          </a:xfrm>
+          <a:prstGeom prst="rightArrow">
+            <a:avLst/>
+          </a:prstGeom>
+        </p:spPr>
+        <p:style>
+          <a:lnRef idx="1">
+            <a:schemeClr val="accent1"/>
+          </a:lnRef>
+          <a:fillRef idx="3">
+            <a:schemeClr val="accent1"/>
+          </a:fillRef>
+          <a:effectRef idx="2">
+            <a:schemeClr val="accent1"/>
+          </a:effectRef>
+          <a:fontRef idx="minor">
+            <a:schemeClr val="lt1"/>
+          </a:fontRef>
+        </p:style>
+        <p:txBody>
+          <a:bodyPr rtlCol="0" anchor="ctr"/>
+          <a:lstStyle/>
+          <a:p>
+            <a:pPr algn="ctr"/>
+          </a:p>
+        </p:txBody>
+      </p:sp>
+      <p:sp>
+        <p:nvSpPr>
+          <p:cNvPr id="8" name="Right Arrow 7"/>
+          <p:cNvSpPr/>
+          <p:nvPr/>
+        </p:nvSpPr>
+        <p:spPr>
+          <a:xfrm>
+            <a:off x="6035040" y="1783080"/>
+            <a:ext cx="457200" cy="320040"/>
+          </a:xfrm>
+          <a:prstGeom prst="rightArrow">
+            <a:avLst/>
+          </a:prstGeom>
+        </p:spPr>
+        <p:style>
+          <a:lnRef idx="1">
+            <a:schemeClr val="accent1"/>
+          </a:lnRef>
+          <a:fillRef idx="3">
+            <a:schemeClr val="accent1"/>
+          </a:fillRef>
+          <a:effectRef idx="2">
+            <a:schemeClr val="accent1"/>
+          </a:effectRef>
+          <a:fontRef idx="minor">
+            <a:schemeClr val="lt1"/>
+          </a:fontRef>
+        </p:style>
+        <p:txBody>
+          <a:bodyPr rtlCol="0" anchor="ctr"/>
+          <a:lstStyle/>
+          <a:p>
+            <a:pPr algn="ctr"/>
+          </a:p>
+        </p:txBody>
+      </p:sp>
+      <p:sp>
+        <p:nvSpPr>
+          <p:cNvPr id="9" name="Right Arrow 8"/>
+          <p:cNvSpPr/>
+          <p:nvPr/>
+        </p:nvSpPr>
+        <p:spPr>
+          <a:xfrm>
+            <a:off x="9052560" y="1783080"/>
+            <a:ext cx="365760" cy="320040"/>
+          </a:xfrm>
+          <a:prstGeom prst="rightArrow">
+            <a:avLst/>
+          </a:prstGeom>
+        </p:spPr>
+        <p:style>
+          <a:lnRef idx="1">
+            <a:schemeClr val="accent1"/>
+          </a:lnRef>
+          <a:fillRef idx="3">
+            <a:schemeClr val="accent1"/>
+          </a:fillRef>
+          <a:effectRef idx="2">
+            <a:schemeClr val="accent1"/>
+          </a:effectRef>
+          <a:fontRef idx="minor">
+            <a:schemeClr val="lt1"/>
+          </a:fontRef>
+        </p:style>
+        <p:txBody>
+          <a:bodyPr rtlCol="0" anchor="ctr"/>
+          <a:lstStyle/>
+          <a:p>
+            <a:pPr algn="ctr"/>
+          </a:p>
+        </p:txBody>
+      </p:sp>
+      <p:sp>
+        <p:nvSpPr>
+          <p:cNvPr id="10" name="Rounded Rectangle 9"/>
+          <p:cNvSpPr/>
+          <p:nvPr/>
+        </p:nvSpPr>
+        <p:spPr>
+          <a:xfrm>
+            <a:off x="3657600" y="2926080"/>
+            <a:ext cx="4389120" cy="914400"/>
+          </a:xfrm>
+          <a:prstGeom prst="roundRect">
+            <a:avLst/>
+          </a:prstGeom>
+          <a:solidFill>
+            <a:srgbClr val="FFF6DF"/>
+          </a:solidFill>
+        </p:spPr>
+        <p:style>
+          <a:lnRef idx="1">
+            <a:schemeClr val="accent1"/>
+          </a:lnRef>
+          <a:fillRef idx="3">
+            <a:schemeClr val="accent1"/>
+          </a:fillRef>
+          <a:effectRef idx="2">
+            <a:schemeClr val="accent1"/>
+          </a:effectRef>
+          <a:fontRef idx="minor">
+            <a:schemeClr val="lt1"/>
+          </a:fontRef>
+        </p:style>
+        <p:txBody>
+          <a:bodyPr rtlCol="0" anchor="ctr"/>
+          <a:lstStyle/>
+          <a:p>
+            <a:r>
+              <a:t>Weekly Validation DAG</a:t>
+            </a:r>
+          </a:p>
+          <a:p>
+            <a:r>
+              <a:t>Walk-forward + Model Select + Threshold Sweep</a:t>
             </a:r>
           </a:p>
         </p:txBody>
@@ -3734,12 +3720,7 @@
           <a:lstStyle/>
           <a:p>
             <a:r>
-              <a:rPr sz="3400">
-                <a:solidFill>
-                  <a:srgbClr val="0B2545"/>
-                </a:solidFill>
-              </a:rPr>
-              <a:t>Product Architecture</a:t>
+              <a:t>What Changed Recently</a:t>
             </a:r>
           </a:p>
         </p:txBody>
@@ -3763,7 +3744,7 @@
               <a:defRPr sz="2100"/>
             </a:pPr>
             <a:r>
-              <a:t>Orchestration: Airflow DAG ai_quant_daily_pipeline</a:t>
+              <a:t>Spark EMA/MACD/RSI/Stochastic logic corrected and validated.</a:t>
             </a:r>
           </a:p>
           <a:p>
@@ -3771,7 +3752,7 @@
               <a:defRPr sz="2100"/>
             </a:pPr>
             <a:r>
-              <a:t>Storage: Postgres schemas bronze, silver, gold, audit</a:t>
+              <a:t>Phase-2 walk-forward evaluator added with auto model selection.</a:t>
             </a:r>
           </a:p>
           <a:p>
@@ -3779,15 +3760,15 @@
               <a:defRPr sz="2100"/>
             </a:pPr>
             <a:r>
-              <a:t>Processing: PySpark ETL + sklearn model pipeline</a:t>
+              <a:t>Weekly validation DAG added for governance.</a:t>
             </a:r>
           </a:p>
           <a:p>
             <a:pPr>
-              <a:defRPr sz="2100"/>
+              <a:defRPr sz="1800"/>
             </a:pPr>
             <a:r>
-              <a:t>Surfaces: Streamlit, FastAPI, Email report</a:t>
+              <a:t>Email report now includes Validation Summary sheet + snapshot text.</a:t>
             </a:r>
           </a:p>
         </p:txBody>
@@ -3826,12 +3807,7 @@
           <a:lstStyle/>
           <a:p>
             <a:r>
-              <a:rPr sz="3400">
-                <a:solidFill>
-                  <a:srgbClr val="0B2545"/>
-                </a:solidFill>
-              </a:rPr>
-              <a:t>DAG Strategy</a:t>
+              <a:t>Silver Layer Indicators</a:t>
             </a:r>
           </a:p>
         </p:txBody>
@@ -3855,7 +3831,7 @@
               <a:defRPr sz="2100"/>
             </a:pPr>
             <a:r>
-              <a:t>Parallel start: crypto + nifty50</a:t>
+              <a:t>Trend: MA7, EMA20, SMA50, SMA200</a:t>
             </a:r>
           </a:p>
           <a:p>
@@ -3863,7 +3839,7 @@
               <a:defRPr sz="2100"/>
             </a:pPr>
             <a:r>
-              <a:t>Sequential heavy branches: midcap -&gt; smallcap -&gt; mutual_funds</a:t>
+              <a:t>Momentum: MACD, MACD Signal, RSI14, Stoch K/D</a:t>
             </a:r>
           </a:p>
           <a:p>
@@ -3871,15 +3847,15 @@
               <a:defRPr sz="2100"/>
             </a:pPr>
             <a:r>
-              <a:t>Per-branch chain: ingest -&gt; etl -&gt; train -&gt; signals -&gt; audit -&gt; quality -&gt; reconcile</a:t>
+              <a:t>Risk: Volatility7d, ATR14, Bollinger Bands</a:t>
             </a:r>
           </a:p>
           <a:p>
             <a:pPr>
-              <a:defRPr sz="2100"/>
+              <a:defRPr sz="1800"/>
             </a:pPr>
             <a:r>
-              <a:t>Global finish: daily audit report -&gt; opportunity email</a:t>
+              <a:t>All computed via Spark windows partitioned by symbol and ordered by event_time</a:t>
             </a:r>
           </a:p>
         </p:txBody>
@@ -3918,12 +3894,7 @@
           <a:lstStyle/>
           <a:p>
             <a:r>
-              <a:rPr sz="3400">
-                <a:solidFill>
-                  <a:srgbClr val="0B2545"/>
-                </a:solidFill>
-              </a:rPr>
-              <a:t>Medallion Data Flow</a:t>
+              <a:t>Modeling and Signals</a:t>
             </a:r>
           </a:p>
         </p:txBody>
@@ -3947,7 +3918,23 @@
               <a:defRPr sz="2100"/>
             </a:pPr>
             <a:r>
-              <a:t>Bronze: source-aligned raw OHLCV/NAV</a:t>
+              <a:t>Horizon labels: 1y (&gt;=10%), 5y (&gt;=50%) using SQL LEAD(close).</a:t>
+            </a:r>
+          </a:p>
+          <a:p>
+            <a:pPr>
+              <a:defRPr sz="1800"/>
+            </a:pPr>
+            <a:r>
+              <a:t>Training model artifacts: /opt/airflow/models/*_rf_1y/5y_model.joblib</a:t>
+            </a:r>
+          </a:p>
+          <a:p>
+            <a:pPr>
+              <a:defRPr sz="1800"/>
+            </a:pPr>
+            <a:r>
+              <a:t>Signal labels come from probability thresholds in strategy_engine.py</a:t>
             </a:r>
           </a:p>
           <a:p>
@@ -3955,23 +3942,7 @@
               <a:defRPr sz="2100"/>
             </a:pPr>
             <a:r>
-              <a:t>Silver: deterministic technical indicators</a:t>
-            </a:r>
-          </a:p>
-          <a:p>
-            <a:pPr>
-              <a:defRPr sz="2100"/>
-            </a:pPr>
-            <a:r>
-              <a:t>Gold: business-ready signal/confidence tables</a:t>
-            </a:r>
-          </a:p>
-          <a:p>
-            <a:pPr>
-              <a:defRPr sz="2100"/>
-            </a:pPr>
-            <a:r>
-              <a:t>Audit: reconciliation + quality + process observability</a:t>
+              <a:t>Gold tables store signal_1y, signal_5y and confidence columns.</a:t>
             </a:r>
           </a:p>
         </p:txBody>
@@ -4010,12 +3981,7 @@
           <a:lstStyle/>
           <a:p>
             <a:r>
-              <a:rPr sz="3400">
-                <a:solidFill>
-                  <a:srgbClr val="0B2545"/>
-                </a:solidFill>
-              </a:rPr>
-              <a:t>pyspark_etl.py Responsibilities</a:t>
+              <a:t>Walk-Forward Evaluation Module</a:t>
             </a:r>
           </a:p>
         </p:txBody>
@@ -4034,12 +4000,28 @@
         <p:txBody>
           <a:bodyPr/>
           <a:lstStyle/>
+          <a:p>
+            <a:pPr>
+              <a:defRPr sz="1800"/>
+            </a:pPr>
+            <a:r>
+              <a:t>Expanding windows: min_train_days=504, test_days=126, step_days=63</a:t>
+            </a:r>
+          </a:p>
           <a:p>
             <a:pPr>
               <a:defRPr sz="2100"/>
             </a:pPr>
             <a:r>
-              <a:t>Create Spark session tuned for Docker constraints</a:t>
+              <a:t>Metrics: accuracy, precision, recall, F1, ROC-AUC, Brier</a:t>
+            </a:r>
+          </a:p>
+          <a:p>
+            <a:pPr>
+              <a:defRPr sz="1800"/>
+            </a:pPr>
+            <a:r>
+              <a:t>Backtest stats: CAGR, Sharpe, drawdown, hit rate (horizon-aware annualization)</a:t>
             </a:r>
           </a:p>
           <a:p>
@@ -4047,23 +4029,7 @@
               <a:defRPr sz="2100"/>
             </a:pPr>
             <a:r>
-              <a:t>Read source via JDBC with adaptive partitioning</a:t>
-            </a:r>
-          </a:p>
-          <a:p>
-            <a:pPr>
-              <a:defRPr sz="2100"/>
-            </a:pPr>
-            <a:r>
-              <a:t>Compute technical indicators in distributed windows</a:t>
-            </a:r>
-          </a:p>
-          <a:p>
-            <a:pPr>
-              <a:defRPr sz="2100"/>
-            </a:pPr>
-            <a:r>
-              <a:t>Persist feature tables efficiently to PostgreSQL</a:t>
+              <a:t>Threshold sweep and recommended min_prob per horizon</a:t>
             </a:r>
           </a:p>
         </p:txBody>
@@ -4102,64 +4068,1205 @@
           <a:lstStyle/>
           <a:p>
             <a:r>
-              <a:rPr sz="3400">
-                <a:solidFill>
-                  <a:srgbClr val="0B2545"/>
-                </a:solidFill>
-              </a:rPr>
-              <a:t>Spark Tuning in Code</a:t>
-            </a:r>
-          </a:p>
-        </p:txBody>
-      </p:sp>
-      <p:sp>
-        <p:nvSpPr>
-          <p:cNvPr id="3" name="Content Placeholder 2"/>
-          <p:cNvSpPr>
-            <a:spLocks noGrp="1"/>
-          </p:cNvSpPr>
-          <p:nvPr>
-            <p:ph idx="1"/>
-          </p:nvPr>
-        </p:nvSpPr>
-        <p:spPr/>
-        <p:txBody>
-          <a:bodyPr/>
-          <a:lstStyle/>
-          <a:p>
-            <a:pPr>
-              <a:defRPr sz="2100"/>
-            </a:pPr>
-            <a:r>
-              <a:t>spark.driver.memory=2g, spark.executor.memory=3g</a:t>
-            </a:r>
-          </a:p>
-          <a:p>
-            <a:pPr>
-              <a:defRPr sz="2100"/>
-            </a:pPr>
-            <a:r>
-              <a:t>spark.sql.shuffle.partitions=20, adaptive execution enabled</a:t>
-            </a:r>
-          </a:p>
-          <a:p>
-            <a:pPr>
-              <a:defRPr sz="2100"/>
-            </a:pPr>
-            <a:r>
-              <a:t>postgres JDBC jar configured for direct read/write</a:t>
-            </a:r>
-          </a:p>
-          <a:p>
-            <a:pPr>
-              <a:defRPr sz="2100"/>
-            </a:pPr>
-            <a:r>
-              <a:t>memory.fraction/storageFraction tuned for heavy transforms</a:t>
-            </a:r>
-          </a:p>
-        </p:txBody>
-      </p:sp>
+              <a:t>Live Validation Snapshot</a:t>
+            </a:r>
+          </a:p>
+        </p:txBody>
+      </p:sp>
+      <p:graphicFrame>
+        <p:nvGraphicFramePr>
+          <p:cNvPr id="3" name="Table 2"/>
+          <p:cNvGraphicFramePr>
+            <a:graphicFrameLocks noGrp="1"/>
+          </p:cNvGraphicFramePr>
+          <p:nvPr/>
+        </p:nvGraphicFramePr>
+        <p:xfrm>
+          <a:off x="274320" y="1188720"/>
+          <a:ext cx="11612880" cy="4297680"/>
+        </p:xfrm>
+        <a:graphic>
+          <a:graphicData uri="http://schemas.openxmlformats.org/drawingml/2006/table">
+            <a:tbl>
+              <a:tblPr firstRow="1" bandRow="1">
+                <a:tableStyleId>{5C22544A-7EE6-4342-B048-85BDC9FD1C3A}</a:tableStyleId>
+              </a:tblPr>
+              <a:tblGrid>
+                <a:gridCol w="1451610"/>
+                <a:gridCol w="1451610"/>
+                <a:gridCol w="1451610"/>
+                <a:gridCol w="1451610"/>
+                <a:gridCol w="1451610"/>
+                <a:gridCol w="1451610"/>
+                <a:gridCol w="1451610"/>
+                <a:gridCol w="1451610"/>
+              </a:tblGrid>
+              <a:tr h="477520">
+                <a:tc>
+                  <a:txBody>
+                    <a:bodyPr/>
+                    <a:lstStyle/>
+                    <a:p>
+                      <a:pPr>
+                        <a:defRPr b="1" sz="1200">
+                          <a:solidFill>
+                            <a:srgbClr val="FFFFFF"/>
+                          </a:solidFill>
+                        </a:defRPr>
+                      </a:pPr>
+                      <a:r>
+                        <a:t>Asset</a:t>
+                      </a:r>
+                    </a:p>
+                  </a:txBody>
+                  <a:tcPr>
+                    <a:solidFill>
+                      <a:srgbClr val="153E75"/>
+                    </a:solidFill>
+                  </a:tcPr>
+                </a:tc>
+                <a:tc>
+                  <a:txBody>
+                    <a:bodyPr/>
+                    <a:lstStyle/>
+                    <a:p>
+                      <a:pPr>
+                        <a:defRPr b="1" sz="1200">
+                          <a:solidFill>
+                            <a:srgbClr val="FFFFFF"/>
+                          </a:solidFill>
+                        </a:defRPr>
+                      </a:pPr>
+                      <a:r>
+                        <a:t>H</a:t>
+                      </a:r>
+                    </a:p>
+                  </a:txBody>
+                  <a:tcPr>
+                    <a:solidFill>
+                      <a:srgbClr val="153E75"/>
+                    </a:solidFill>
+                  </a:tcPr>
+                </a:tc>
+                <a:tc>
+                  <a:txBody>
+                    <a:bodyPr/>
+                    <a:lstStyle/>
+                    <a:p>
+                      <a:pPr>
+                        <a:defRPr b="1" sz="1200">
+                          <a:solidFill>
+                            <a:srgbClr val="FFFFFF"/>
+                          </a:solidFill>
+                        </a:defRPr>
+                      </a:pPr>
+                      <a:r>
+                        <a:t>Status</a:t>
+                      </a:r>
+                    </a:p>
+                  </a:txBody>
+                  <a:tcPr>
+                    <a:solidFill>
+                      <a:srgbClr val="153E75"/>
+                    </a:solidFill>
+                  </a:tcPr>
+                </a:tc>
+                <a:tc>
+                  <a:txBody>
+                    <a:bodyPr/>
+                    <a:lstStyle/>
+                    <a:p>
+                      <a:pPr>
+                        <a:defRPr b="1" sz="1200">
+                          <a:solidFill>
+                            <a:srgbClr val="FFFFFF"/>
+                          </a:solidFill>
+                        </a:defRPr>
+                      </a:pPr>
+                      <a:r>
+                        <a:t>Model</a:t>
+                      </a:r>
+                    </a:p>
+                  </a:txBody>
+                  <a:tcPr>
+                    <a:solidFill>
+                      <a:srgbClr val="153E75"/>
+                    </a:solidFill>
+                  </a:tcPr>
+                </a:tc>
+                <a:tc>
+                  <a:txBody>
+                    <a:bodyPr/>
+                    <a:lstStyle/>
+                    <a:p>
+                      <a:pPr>
+                        <a:defRPr b="1" sz="1200">
+                          <a:solidFill>
+                            <a:srgbClr val="FFFFFF"/>
+                          </a:solidFill>
+                        </a:defRPr>
+                      </a:pPr>
+                      <a:r>
+                        <a:t>Thr</a:t>
+                      </a:r>
+                    </a:p>
+                  </a:txBody>
+                  <a:tcPr>
+                    <a:solidFill>
+                      <a:srgbClr val="153E75"/>
+                    </a:solidFill>
+                  </a:tcPr>
+                </a:tc>
+                <a:tc>
+                  <a:txBody>
+                    <a:bodyPr/>
+                    <a:lstStyle/>
+                    <a:p>
+                      <a:pPr>
+                        <a:defRPr b="1" sz="1200">
+                          <a:solidFill>
+                            <a:srgbClr val="FFFFFF"/>
+                          </a:solidFill>
+                        </a:defRPr>
+                      </a:pPr>
+                      <a:r>
+                        <a:t>ROC</a:t>
+                      </a:r>
+                    </a:p>
+                  </a:txBody>
+                  <a:tcPr>
+                    <a:solidFill>
+                      <a:srgbClr val="153E75"/>
+                    </a:solidFill>
+                  </a:tcPr>
+                </a:tc>
+                <a:tc>
+                  <a:txBody>
+                    <a:bodyPr/>
+                    <a:lstStyle/>
+                    <a:p>
+                      <a:pPr>
+                        <a:defRPr b="1" sz="1200">
+                          <a:solidFill>
+                            <a:srgbClr val="FFFFFF"/>
+                          </a:solidFill>
+                        </a:defRPr>
+                      </a:pPr>
+                      <a:r>
+                        <a:t>F1</a:t>
+                      </a:r>
+                    </a:p>
+                  </a:txBody>
+                  <a:tcPr>
+                    <a:solidFill>
+                      <a:srgbClr val="153E75"/>
+                    </a:solidFill>
+                  </a:tcPr>
+                </a:tc>
+                <a:tc>
+                  <a:txBody>
+                    <a:bodyPr/>
+                    <a:lstStyle/>
+                    <a:p>
+                      <a:pPr>
+                        <a:defRPr b="1" sz="1200">
+                          <a:solidFill>
+                            <a:srgbClr val="FFFFFF"/>
+                          </a:solidFill>
+                        </a:defRPr>
+                      </a:pPr>
+                      <a:r>
+                        <a:t>Splits</a:t>
+                      </a:r>
+                    </a:p>
+                  </a:txBody>
+                  <a:tcPr>
+                    <a:solidFill>
+                      <a:srgbClr val="153E75"/>
+                    </a:solidFill>
+                  </a:tcPr>
+                </a:tc>
+              </a:tr>
+              <a:tr h="477520">
+                <a:tc>
+                  <a:txBody>
+                    <a:bodyPr/>
+                    <a:lstStyle/>
+                    <a:p>
+                      <a:pPr>
+                        <a:defRPr sz="1100"/>
+                      </a:pPr>
+                      <a:r>
+                        <a:t>Nifty 50</a:t>
+                      </a:r>
+                    </a:p>
+                  </a:txBody>
+                  <a:tcPr/>
+                </a:tc>
+                <a:tc>
+                  <a:txBody>
+                    <a:bodyPr/>
+                    <a:lstStyle/>
+                    <a:p>
+                      <a:pPr>
+                        <a:defRPr sz="1100"/>
+                      </a:pPr>
+                      <a:r>
+                        <a:t>1y</a:t>
+                      </a:r>
+                    </a:p>
+                  </a:txBody>
+                  <a:tcPr/>
+                </a:tc>
+                <a:tc>
+                  <a:txBody>
+                    <a:bodyPr/>
+                    <a:lstStyle/>
+                    <a:p>
+                      <a:pPr>
+                        <a:defRPr sz="1100"/>
+                      </a:pPr>
+                      <a:r>
+                        <a:t>ok</a:t>
+                      </a:r>
+                    </a:p>
+                  </a:txBody>
+                  <a:tcPr/>
+                </a:tc>
+                <a:tc>
+                  <a:txBody>
+                    <a:bodyPr/>
+                    <a:lstStyle/>
+                    <a:p>
+                      <a:pPr>
+                        <a:defRPr sz="1100"/>
+                      </a:pPr>
+                      <a:r>
+                        <a:t>histgb</a:t>
+                      </a:r>
+                    </a:p>
+                  </a:txBody>
+                  <a:tcPr/>
+                </a:tc>
+                <a:tc>
+                  <a:txBody>
+                    <a:bodyPr/>
+                    <a:lstStyle/>
+                    <a:p>
+                      <a:pPr>
+                        <a:defRPr sz="1100"/>
+                      </a:pPr>
+                      <a:r>
+                        <a:t>70%</a:t>
+                      </a:r>
+                    </a:p>
+                  </a:txBody>
+                  <a:tcPr/>
+                </a:tc>
+                <a:tc>
+                  <a:txBody>
+                    <a:bodyPr/>
+                    <a:lstStyle/>
+                    <a:p>
+                      <a:pPr>
+                        <a:defRPr sz="1100"/>
+                      </a:pPr>
+                      <a:r>
+                        <a:t>0.565</a:t>
+                      </a:r>
+                    </a:p>
+                  </a:txBody>
+                  <a:tcPr/>
+                </a:tc>
+                <a:tc>
+                  <a:txBody>
+                    <a:bodyPr/>
+                    <a:lstStyle/>
+                    <a:p>
+                      <a:pPr>
+                        <a:defRPr sz="1100"/>
+                      </a:pPr>
+                      <a:r>
+                        <a:t>0.639</a:t>
+                      </a:r>
+                    </a:p>
+                  </a:txBody>
+                  <a:tcPr/>
+                </a:tc>
+                <a:tc>
+                  <a:txBody>
+                    <a:bodyPr/>
+                    <a:lstStyle/>
+                    <a:p>
+                      <a:pPr>
+                        <a:defRPr sz="1100"/>
+                      </a:pPr>
+                      <a:r>
+                        <a:t>26</a:t>
+                      </a:r>
+                    </a:p>
+                  </a:txBody>
+                  <a:tcPr/>
+                </a:tc>
+              </a:tr>
+              <a:tr h="477520">
+                <a:tc>
+                  <a:txBody>
+                    <a:bodyPr/>
+                    <a:lstStyle/>
+                    <a:p>
+                      <a:pPr>
+                        <a:defRPr sz="1100"/>
+                      </a:pPr>
+                      <a:r>
+                        <a:t>Nifty 50</a:t>
+                      </a:r>
+                    </a:p>
+                  </a:txBody>
+                  <a:tcPr/>
+                </a:tc>
+                <a:tc>
+                  <a:txBody>
+                    <a:bodyPr/>
+                    <a:lstStyle/>
+                    <a:p>
+                      <a:pPr>
+                        <a:defRPr sz="1100"/>
+                      </a:pPr>
+                      <a:r>
+                        <a:t>5y</a:t>
+                      </a:r>
+                    </a:p>
+                  </a:txBody>
+                  <a:tcPr/>
+                </a:tc>
+                <a:tc>
+                  <a:txBody>
+                    <a:bodyPr/>
+                    <a:lstStyle/>
+                    <a:p>
+                      <a:pPr>
+                        <a:defRPr sz="1100"/>
+                      </a:pPr>
+                      <a:r>
+                        <a:t>ok</a:t>
+                      </a:r>
+                    </a:p>
+                  </a:txBody>
+                  <a:tcPr/>
+                </a:tc>
+                <a:tc>
+                  <a:txBody>
+                    <a:bodyPr/>
+                    <a:lstStyle/>
+                    <a:p>
+                      <a:pPr>
+                        <a:defRPr sz="1100"/>
+                      </a:pPr>
+                      <a:r>
+                        <a:t>histgb</a:t>
+                      </a:r>
+                    </a:p>
+                  </a:txBody>
+                  <a:tcPr/>
+                </a:tc>
+                <a:tc>
+                  <a:txBody>
+                    <a:bodyPr/>
+                    <a:lstStyle/>
+                    <a:p>
+                      <a:pPr>
+                        <a:defRPr sz="1100"/>
+                      </a:pPr>
+                      <a:r>
+                        <a:t>50%</a:t>
+                      </a:r>
+                    </a:p>
+                  </a:txBody>
+                  <a:tcPr/>
+                </a:tc>
+                <a:tc>
+                  <a:txBody>
+                    <a:bodyPr/>
+                    <a:lstStyle/>
+                    <a:p>
+                      <a:pPr>
+                        <a:defRPr sz="1100"/>
+                      </a:pPr>
+                      <a:r>
+                        <a:t>0.638</a:t>
+                      </a:r>
+                    </a:p>
+                  </a:txBody>
+                  <a:tcPr/>
+                </a:tc>
+                <a:tc>
+                  <a:txBody>
+                    <a:bodyPr/>
+                    <a:lstStyle/>
+                    <a:p>
+                      <a:pPr>
+                        <a:defRPr sz="1100"/>
+                      </a:pPr>
+                      <a:r>
+                        <a:t>0.924</a:t>
+                      </a:r>
+                    </a:p>
+                  </a:txBody>
+                  <a:tcPr/>
+                </a:tc>
+                <a:tc>
+                  <a:txBody>
+                    <a:bodyPr/>
+                    <a:lstStyle/>
+                    <a:p>
+                      <a:pPr>
+                        <a:defRPr sz="1100"/>
+                      </a:pPr>
+                      <a:r>
+                        <a:t>10</a:t>
+                      </a:r>
+                    </a:p>
+                  </a:txBody>
+                  <a:tcPr/>
+                </a:tc>
+              </a:tr>
+              <a:tr h="477520">
+                <a:tc>
+                  <a:txBody>
+                    <a:bodyPr/>
+                    <a:lstStyle/>
+                    <a:p>
+                      <a:pPr>
+                        <a:defRPr sz="1100"/>
+                      </a:pPr>
+                      <a:r>
+                        <a:t>Nifty Mid Cap</a:t>
+                      </a:r>
+                    </a:p>
+                  </a:txBody>
+                  <a:tcPr/>
+                </a:tc>
+                <a:tc>
+                  <a:txBody>
+                    <a:bodyPr/>
+                    <a:lstStyle/>
+                    <a:p>
+                      <a:pPr>
+                        <a:defRPr sz="1100"/>
+                      </a:pPr>
+                      <a:r>
+                        <a:t>1y</a:t>
+                      </a:r>
+                    </a:p>
+                  </a:txBody>
+                  <a:tcPr/>
+                </a:tc>
+                <a:tc>
+                  <a:txBody>
+                    <a:bodyPr/>
+                    <a:lstStyle/>
+                    <a:p>
+                      <a:pPr>
+                        <a:defRPr sz="1100"/>
+                      </a:pPr>
+                      <a:r>
+                        <a:t>ok</a:t>
+                      </a:r>
+                    </a:p>
+                  </a:txBody>
+                  <a:tcPr/>
+                </a:tc>
+                <a:tc>
+                  <a:txBody>
+                    <a:bodyPr/>
+                    <a:lstStyle/>
+                    <a:p>
+                      <a:pPr>
+                        <a:defRPr sz="1100"/>
+                      </a:pPr>
+                      <a:r>
+                        <a:t>rf</a:t>
+                      </a:r>
+                    </a:p>
+                  </a:txBody>
+                  <a:tcPr/>
+                </a:tc>
+                <a:tc>
+                  <a:txBody>
+                    <a:bodyPr/>
+                    <a:lstStyle/>
+                    <a:p>
+                      <a:pPr>
+                        <a:defRPr sz="1100"/>
+                      </a:pPr>
+                      <a:r>
+                        <a:t>50%</a:t>
+                      </a:r>
+                    </a:p>
+                  </a:txBody>
+                  <a:tcPr/>
+                </a:tc>
+                <a:tc>
+                  <a:txBody>
+                    <a:bodyPr/>
+                    <a:lstStyle/>
+                    <a:p>
+                      <a:pPr>
+                        <a:defRPr sz="1100"/>
+                      </a:pPr>
+                      <a:r>
+                        <a:t>0.544</a:t>
+                      </a:r>
+                    </a:p>
+                  </a:txBody>
+                  <a:tcPr/>
+                </a:tc>
+                <a:tc>
+                  <a:txBody>
+                    <a:bodyPr/>
+                    <a:lstStyle/>
+                    <a:p>
+                      <a:pPr>
+                        <a:defRPr sz="1100"/>
+                      </a:pPr>
+                      <a:r>
+                        <a:t>0.537</a:t>
+                      </a:r>
+                    </a:p>
+                  </a:txBody>
+                  <a:tcPr/>
+                </a:tc>
+                <a:tc>
+                  <a:txBody>
+                    <a:bodyPr/>
+                    <a:lstStyle/>
+                    <a:p>
+                      <a:pPr>
+                        <a:defRPr sz="1100"/>
+                      </a:pPr>
+                      <a:r>
+                        <a:t>26</a:t>
+                      </a:r>
+                    </a:p>
+                  </a:txBody>
+                  <a:tcPr/>
+                </a:tc>
+              </a:tr>
+              <a:tr h="477520">
+                <a:tc>
+                  <a:txBody>
+                    <a:bodyPr/>
+                    <a:lstStyle/>
+                    <a:p>
+                      <a:pPr>
+                        <a:defRPr sz="1100"/>
+                      </a:pPr>
+                      <a:r>
+                        <a:t>Nifty Mid Cap</a:t>
+                      </a:r>
+                    </a:p>
+                  </a:txBody>
+                  <a:tcPr/>
+                </a:tc>
+                <a:tc>
+                  <a:txBody>
+                    <a:bodyPr/>
+                    <a:lstStyle/>
+                    <a:p>
+                      <a:pPr>
+                        <a:defRPr sz="1100"/>
+                      </a:pPr>
+                      <a:r>
+                        <a:t>5y</a:t>
+                      </a:r>
+                    </a:p>
+                  </a:txBody>
+                  <a:tcPr/>
+                </a:tc>
+                <a:tc>
+                  <a:txBody>
+                    <a:bodyPr/>
+                    <a:lstStyle/>
+                    <a:p>
+                      <a:pPr>
+                        <a:defRPr sz="1100"/>
+                      </a:pPr>
+                      <a:r>
+                        <a:t>ok</a:t>
+                      </a:r>
+                    </a:p>
+                  </a:txBody>
+                  <a:tcPr/>
+                </a:tc>
+                <a:tc>
+                  <a:txBody>
+                    <a:bodyPr/>
+                    <a:lstStyle/>
+                    <a:p>
+                      <a:pPr>
+                        <a:defRPr sz="1100"/>
+                      </a:pPr>
+                      <a:r>
+                        <a:t>rf</a:t>
+                      </a:r>
+                    </a:p>
+                  </a:txBody>
+                  <a:tcPr/>
+                </a:tc>
+                <a:tc>
+                  <a:txBody>
+                    <a:bodyPr/>
+                    <a:lstStyle/>
+                    <a:p>
+                      <a:pPr>
+                        <a:defRPr sz="1100"/>
+                      </a:pPr>
+                      <a:r>
+                        <a:t>50%</a:t>
+                      </a:r>
+                    </a:p>
+                  </a:txBody>
+                  <a:tcPr/>
+                </a:tc>
+                <a:tc>
+                  <a:txBody>
+                    <a:bodyPr/>
+                    <a:lstStyle/>
+                    <a:p>
+                      <a:pPr>
+                        <a:defRPr sz="1100"/>
+                      </a:pPr>
+                      <a:r>
+                        <a:t>0.552</a:t>
+                      </a:r>
+                    </a:p>
+                  </a:txBody>
+                  <a:tcPr/>
+                </a:tc>
+                <a:tc>
+                  <a:txBody>
+                    <a:bodyPr/>
+                    <a:lstStyle/>
+                    <a:p>
+                      <a:pPr>
+                        <a:defRPr sz="1100"/>
+                      </a:pPr>
+                      <a:r>
+                        <a:t>0.731</a:t>
+                      </a:r>
+                    </a:p>
+                  </a:txBody>
+                  <a:tcPr/>
+                </a:tc>
+                <a:tc>
+                  <a:txBody>
+                    <a:bodyPr/>
+                    <a:lstStyle/>
+                    <a:p>
+                      <a:pPr>
+                        <a:defRPr sz="1100"/>
+                      </a:pPr>
+                      <a:r>
+                        <a:t>10</a:t>
+                      </a:r>
+                    </a:p>
+                  </a:txBody>
+                  <a:tcPr/>
+                </a:tc>
+              </a:tr>
+              <a:tr h="477520">
+                <a:tc>
+                  <a:txBody>
+                    <a:bodyPr/>
+                    <a:lstStyle/>
+                    <a:p>
+                      <a:pPr>
+                        <a:defRPr sz="1100"/>
+                      </a:pPr>
+                      <a:r>
+                        <a:t>Nifty Small Cap</a:t>
+                      </a:r>
+                    </a:p>
+                  </a:txBody>
+                  <a:tcPr/>
+                </a:tc>
+                <a:tc>
+                  <a:txBody>
+                    <a:bodyPr/>
+                    <a:lstStyle/>
+                    <a:p>
+                      <a:pPr>
+                        <a:defRPr sz="1100"/>
+                      </a:pPr>
+                      <a:r>
+                        <a:t>n/a</a:t>
+                      </a:r>
+                    </a:p>
+                  </a:txBody>
+                  <a:tcPr/>
+                </a:tc>
+                <a:tc>
+                  <a:txBody>
+                    <a:bodyPr/>
+                    <a:lstStyle/>
+                    <a:p>
+                      <a:pPr>
+                        <a:defRPr sz="1100"/>
+                      </a:pPr>
+                      <a:r>
+                        <a:t>missing_report</a:t>
+                      </a:r>
+                    </a:p>
+                  </a:txBody>
+                  <a:tcPr/>
+                </a:tc>
+                <a:tc>
+                  <a:txBody>
+                    <a:bodyPr/>
+                    <a:lstStyle/>
+                    <a:p>
+                      <a:pPr>
+                        <a:defRPr sz="1100"/>
+                      </a:pPr>
+                      <a:r>
+                        <a:t>n/a</a:t>
+                      </a:r>
+                    </a:p>
+                  </a:txBody>
+                  <a:tcPr/>
+                </a:tc>
+                <a:tc>
+                  <a:txBody>
+                    <a:bodyPr/>
+                    <a:lstStyle/>
+                    <a:p>
+                      <a:pPr>
+                        <a:defRPr sz="1100"/>
+                      </a:pPr>
+                      <a:r>
+                        <a:t>n/a</a:t>
+                      </a:r>
+                    </a:p>
+                  </a:txBody>
+                  <a:tcPr/>
+                </a:tc>
+                <a:tc>
+                  <a:txBody>
+                    <a:bodyPr/>
+                    <a:lstStyle/>
+                    <a:p>
+                      <a:pPr>
+                        <a:defRPr sz="1100"/>
+                      </a:pPr>
+                      <a:r>
+                        <a:t>n/a</a:t>
+                      </a:r>
+                    </a:p>
+                  </a:txBody>
+                  <a:tcPr/>
+                </a:tc>
+                <a:tc>
+                  <a:txBody>
+                    <a:bodyPr/>
+                    <a:lstStyle/>
+                    <a:p>
+                      <a:pPr>
+                        <a:defRPr sz="1100"/>
+                      </a:pPr>
+                      <a:r>
+                        <a:t>n/a</a:t>
+                      </a:r>
+                    </a:p>
+                  </a:txBody>
+                  <a:tcPr/>
+                </a:tc>
+                <a:tc>
+                  <a:txBody>
+                    <a:bodyPr/>
+                    <a:lstStyle/>
+                    <a:p>
+                      <a:pPr>
+                        <a:defRPr sz="1100"/>
+                      </a:pPr>
+                      <a:r>
+                        <a:t>n/a</a:t>
+                      </a:r>
+                    </a:p>
+                  </a:txBody>
+                  <a:tcPr/>
+                </a:tc>
+              </a:tr>
+              <a:tr h="477520">
+                <a:tc>
+                  <a:txBody>
+                    <a:bodyPr/>
+                    <a:lstStyle/>
+                    <a:p>
+                      <a:pPr>
+                        <a:defRPr sz="1100"/>
+                      </a:pPr>
+                      <a:r>
+                        <a:t>Mutual Funds</a:t>
+                      </a:r>
+                    </a:p>
+                  </a:txBody>
+                  <a:tcPr/>
+                </a:tc>
+                <a:tc>
+                  <a:txBody>
+                    <a:bodyPr/>
+                    <a:lstStyle/>
+                    <a:p>
+                      <a:pPr>
+                        <a:defRPr sz="1100"/>
+                      </a:pPr>
+                      <a:r>
+                        <a:t>n/a</a:t>
+                      </a:r>
+                    </a:p>
+                  </a:txBody>
+                  <a:tcPr/>
+                </a:tc>
+                <a:tc>
+                  <a:txBody>
+                    <a:bodyPr/>
+                    <a:lstStyle/>
+                    <a:p>
+                      <a:pPr>
+                        <a:defRPr sz="1100"/>
+                      </a:pPr>
+                      <a:r>
+                        <a:t>missing_report</a:t>
+                      </a:r>
+                    </a:p>
+                  </a:txBody>
+                  <a:tcPr/>
+                </a:tc>
+                <a:tc>
+                  <a:txBody>
+                    <a:bodyPr/>
+                    <a:lstStyle/>
+                    <a:p>
+                      <a:pPr>
+                        <a:defRPr sz="1100"/>
+                      </a:pPr>
+                      <a:r>
+                        <a:t>n/a</a:t>
+                      </a:r>
+                    </a:p>
+                  </a:txBody>
+                  <a:tcPr/>
+                </a:tc>
+                <a:tc>
+                  <a:txBody>
+                    <a:bodyPr/>
+                    <a:lstStyle/>
+                    <a:p>
+                      <a:pPr>
+                        <a:defRPr sz="1100"/>
+                      </a:pPr>
+                      <a:r>
+                        <a:t>n/a</a:t>
+                      </a:r>
+                    </a:p>
+                  </a:txBody>
+                  <a:tcPr/>
+                </a:tc>
+                <a:tc>
+                  <a:txBody>
+                    <a:bodyPr/>
+                    <a:lstStyle/>
+                    <a:p>
+                      <a:pPr>
+                        <a:defRPr sz="1100"/>
+                      </a:pPr>
+                      <a:r>
+                        <a:t>n/a</a:t>
+                      </a:r>
+                    </a:p>
+                  </a:txBody>
+                  <a:tcPr/>
+                </a:tc>
+                <a:tc>
+                  <a:txBody>
+                    <a:bodyPr/>
+                    <a:lstStyle/>
+                    <a:p>
+                      <a:pPr>
+                        <a:defRPr sz="1100"/>
+                      </a:pPr>
+                      <a:r>
+                        <a:t>n/a</a:t>
+                      </a:r>
+                    </a:p>
+                  </a:txBody>
+                  <a:tcPr/>
+                </a:tc>
+                <a:tc>
+                  <a:txBody>
+                    <a:bodyPr/>
+                    <a:lstStyle/>
+                    <a:p>
+                      <a:pPr>
+                        <a:defRPr sz="1100"/>
+                      </a:pPr>
+                      <a:r>
+                        <a:t>n/a</a:t>
+                      </a:r>
+                    </a:p>
+                  </a:txBody>
+                  <a:tcPr/>
+                </a:tc>
+              </a:tr>
+              <a:tr h="477520">
+                <a:tc>
+                  <a:txBody>
+                    <a:bodyPr/>
+                    <a:lstStyle/>
+                    <a:p>
+                      <a:pPr>
+                        <a:defRPr sz="1100"/>
+                      </a:pPr>
+                      <a:r>
+                        <a:t>Crypto</a:t>
+                      </a:r>
+                    </a:p>
+                  </a:txBody>
+                  <a:tcPr/>
+                </a:tc>
+                <a:tc>
+                  <a:txBody>
+                    <a:bodyPr/>
+                    <a:lstStyle/>
+                    <a:p>
+                      <a:pPr>
+                        <a:defRPr sz="1100"/>
+                      </a:pPr>
+                      <a:r>
+                        <a:t>1y</a:t>
+                      </a:r>
+                    </a:p>
+                  </a:txBody>
+                  <a:tcPr/>
+                </a:tc>
+                <a:tc>
+                  <a:txBody>
+                    <a:bodyPr/>
+                    <a:lstStyle/>
+                    <a:p>
+                      <a:pPr>
+                        <a:defRPr sz="1100"/>
+                      </a:pPr>
+                      <a:r>
+                        <a:t>ok</a:t>
+                      </a:r>
+                    </a:p>
+                  </a:txBody>
+                  <a:tcPr/>
+                </a:tc>
+                <a:tc>
+                  <a:txBody>
+                    <a:bodyPr/>
+                    <a:lstStyle/>
+                    <a:p>
+                      <a:pPr>
+                        <a:defRPr sz="1100"/>
+                      </a:pPr>
+                      <a:r>
+                        <a:t>histgb</a:t>
+                      </a:r>
+                    </a:p>
+                  </a:txBody>
+                  <a:tcPr/>
+                </a:tc>
+                <a:tc>
+                  <a:txBody>
+                    <a:bodyPr/>
+                    <a:lstStyle/>
+                    <a:p>
+                      <a:pPr>
+                        <a:defRPr sz="1100"/>
+                      </a:pPr>
+                      <a:r>
+                        <a:t>60%</a:t>
+                      </a:r>
+                    </a:p>
+                  </a:txBody>
+                  <a:tcPr/>
+                </a:tc>
+                <a:tc>
+                  <a:txBody>
+                    <a:bodyPr/>
+                    <a:lstStyle/>
+                    <a:p>
+                      <a:pPr>
+                        <a:defRPr sz="1100"/>
+                      </a:pPr>
+                      <a:r>
+                        <a:t>0.550</a:t>
+                      </a:r>
+                    </a:p>
+                  </a:txBody>
+                  <a:tcPr/>
+                </a:tc>
+                <a:tc>
+                  <a:txBody>
+                    <a:bodyPr/>
+                    <a:lstStyle/>
+                    <a:p>
+                      <a:pPr>
+                        <a:defRPr sz="1100"/>
+                      </a:pPr>
+                      <a:r>
+                        <a:t>0.646</a:t>
+                      </a:r>
+                    </a:p>
+                  </a:txBody>
+                  <a:tcPr/>
+                </a:tc>
+                <a:tc>
+                  <a:txBody>
+                    <a:bodyPr/>
+                    <a:lstStyle/>
+                    <a:p>
+                      <a:pPr>
+                        <a:defRPr sz="1100"/>
+                      </a:pPr>
+                      <a:r>
+                        <a:t>2</a:t>
+                      </a:r>
+                    </a:p>
+                  </a:txBody>
+                  <a:tcPr/>
+                </a:tc>
+              </a:tr>
+              <a:tr h="477520">
+                <a:tc>
+                  <a:txBody>
+                    <a:bodyPr/>
+                    <a:lstStyle/>
+                    <a:p>
+                      <a:pPr>
+                        <a:defRPr sz="1100"/>
+                      </a:pPr>
+                      <a:r>
+                        <a:t>Crypto</a:t>
+                      </a:r>
+                    </a:p>
+                  </a:txBody>
+                  <a:tcPr/>
+                </a:tc>
+                <a:tc>
+                  <a:txBody>
+                    <a:bodyPr/>
+                    <a:lstStyle/>
+                    <a:p>
+                      <a:pPr>
+                        <a:defRPr sz="1100"/>
+                      </a:pPr>
+                      <a:r>
+                        <a:t>5y</a:t>
+                      </a:r>
+                    </a:p>
+                  </a:txBody>
+                  <a:tcPr/>
+                </a:tc>
+                <a:tc>
+                  <a:txBody>
+                    <a:bodyPr/>
+                    <a:lstStyle/>
+                    <a:p>
+                      <a:pPr>
+                        <a:defRPr sz="1100"/>
+                      </a:pPr>
+                      <a:r>
+                        <a:t>no_data</a:t>
+                      </a:r>
+                    </a:p>
+                  </a:txBody>
+                  <a:tcPr/>
+                </a:tc>
+                <a:tc>
+                  <a:txBody>
+                    <a:bodyPr/>
+                    <a:lstStyle/>
+                    <a:p>
+                      <a:pPr>
+                        <a:defRPr sz="1100"/>
+                      </a:pPr>
+                      <a:r>
+                        <a:t>histgb</a:t>
+                      </a:r>
+                    </a:p>
+                  </a:txBody>
+                  <a:tcPr/>
+                </a:tc>
+                <a:tc>
+                  <a:txBody>
+                    <a:bodyPr/>
+                    <a:lstStyle/>
+                    <a:p>
+                      <a:pPr>
+                        <a:defRPr sz="1100"/>
+                      </a:pPr>
+                      <a:r>
+                        <a:t>n/a</a:t>
+                      </a:r>
+                    </a:p>
+                  </a:txBody>
+                  <a:tcPr/>
+                </a:tc>
+                <a:tc>
+                  <a:txBody>
+                    <a:bodyPr/>
+                    <a:lstStyle/>
+                    <a:p>
+                      <a:pPr>
+                        <a:defRPr sz="1100"/>
+                      </a:pPr>
+                      <a:r>
+                        <a:t>n/a</a:t>
+                      </a:r>
+                    </a:p>
+                  </a:txBody>
+                  <a:tcPr/>
+                </a:tc>
+                <a:tc>
+                  <a:txBody>
+                    <a:bodyPr/>
+                    <a:lstStyle/>
+                    <a:p>
+                      <a:pPr>
+                        <a:defRPr sz="1100"/>
+                      </a:pPr>
+                      <a:r>
+                        <a:t>n/a</a:t>
+                      </a:r>
+                    </a:p>
+                  </a:txBody>
+                  <a:tcPr/>
+                </a:tc>
+                <a:tc>
+                  <a:txBody>
+                    <a:bodyPr/>
+                    <a:lstStyle/>
+                    <a:p>
+                      <a:pPr>
+                        <a:defRPr sz="1100"/>
+                      </a:pPr>
+                      <a:r>
+                        <a:t>n/a</a:t>
+                      </a:r>
+                    </a:p>
+                  </a:txBody>
+                  <a:tcPr/>
+                </a:tc>
+              </a:tr>
+            </a:tbl>
+          </a:graphicData>
+        </a:graphic>
+      </p:graphicFrame>
     </p:spTree>
   </p:cSld>
   <p:clrMapOvr>
@@ -4194,194 +5301,55 @@
           <a:lstStyle/>
           <a:p>
             <a:r>
-              <a:rPr sz="3400">
-                <a:solidFill>
-                  <a:srgbClr val="0B2545"/>
-                </a:solidFill>
-              </a:rPr>
-              <a:t>JDBC Partition Logic (from run_spark_etl)</a:t>
-            </a:r>
-          </a:p>
-        </p:txBody>
-      </p:sp>
-      <p:sp>
-        <p:nvSpPr>
-          <p:cNvPr id="3" name="TextBox 2"/>
-          <p:cNvSpPr txBox="1"/>
-          <p:nvPr/>
-        </p:nvSpPr>
-        <p:spPr>
-          <a:xfrm>
-            <a:off x="548640" y="1188720"/>
-            <a:ext cx="11064240" cy="4937760"/>
-          </a:xfrm>
-          <a:prstGeom prst="rect">
-            <a:avLst/>
-          </a:prstGeom>
-          <a:noFill/>
-        </p:spPr>
-        <p:txBody>
-          <a:bodyPr wrap="square">
-            <a:spAutoFit/>
-          </a:bodyPr>
+              <a:t>Weekly DAG: ai_quant_model_validation_weekly</a:t>
+            </a:r>
+          </a:p>
+        </p:txBody>
+      </p:sp>
+      <p:sp>
+        <p:nvSpPr>
+          <p:cNvPr id="3" name="Content Placeholder 2"/>
+          <p:cNvSpPr>
+            <a:spLocks noGrp="1"/>
+          </p:cNvSpPr>
+          <p:nvPr>
+            <p:ph idx="1"/>
+          </p:nvPr>
+        </p:nvSpPr>
+        <p:spPr/>
+        <p:txBody>
+          <a:bodyPr/>
           <a:lstStyle/>
           <a:p>
             <a:pPr>
-              <a:defRPr sz="1600">
-                <a:solidFill>
-                  <a:srgbClr val="1E293B"/>
-                </a:solidFill>
-                <a:latin typeface="Consolas"/>
-              </a:defRPr>
+              <a:defRPr sz="1800"/>
             </a:pPr>
             <a:r>
-              <a:t># read metadata</a:t>
+              <a:t>Tasks run sequentially: crypto -&gt; nifty50 -&gt; midcap -&gt; smallcap -&gt; mutual_funds</a:t>
             </a:r>
           </a:p>
           <a:p>
             <a:pPr>
-              <a:defRPr sz="1600">
-                <a:solidFill>
-                  <a:srgbClr val="1E293B"/>
-                </a:solidFill>
-                <a:latin typeface="Consolas"/>
-              </a:defRPr>
+              <a:defRPr sz="1800"/>
             </a:pPr>
             <a:r>
-              <a:t>SELECT MIN(id), MAX(id), COUNT(*) FROM source_table</a:t>
+              <a:t>do_xcom_push=False and return_results=False for lean scheduler load</a:t>
             </a:r>
           </a:p>
           <a:p>
             <a:pPr>
-              <a:defRPr sz="1600">
-                <a:solidFill>
-                  <a:srgbClr val="1E293B"/>
-                </a:solidFill>
-                <a:latin typeface="Consolas"/>
-              </a:defRPr>
+              <a:defRPr sz="1800"/>
             </a:pPr>
+            <a:r>
+              <a:t>max_active_runs=1 to prevent duplicate heavy runs on local hardware</a:t>
+            </a:r>
           </a:p>
           <a:p>
             <a:pPr>
-              <a:defRPr sz="1600">
-                <a:solidFill>
-                  <a:srgbClr val="1E293B"/>
-                </a:solidFill>
-                <a:latin typeface="Consolas"/>
-              </a:defRPr>
+              <a:defRPr sz="2100"/>
             </a:pPr>
             <a:r>
-              <a:t>optimal_partitions = min(max(1, int(sqrt(row_count/100000))), 8)</a:t>
-            </a:r>
-          </a:p>
-          <a:p>
-            <a:pPr>
-              <a:defRPr sz="1600">
-                <a:solidFill>
-                  <a:srgbClr val="1E293B"/>
-                </a:solidFill>
-                <a:latin typeface="Consolas"/>
-              </a:defRPr>
-            </a:pPr>
-          </a:p>
-          <a:p>
-            <a:pPr>
-              <a:defRPr sz="1600">
-                <a:solidFill>
-                  <a:srgbClr val="1E293B"/>
-                </a:solidFill>
-                <a:latin typeface="Consolas"/>
-              </a:defRPr>
-            </a:pPr>
-            <a:r>
-              <a:t>if min_id and max_id:</a:t>
-            </a:r>
-          </a:p>
-          <a:p>
-            <a:pPr>
-              <a:defRPr sz="1600">
-                <a:solidFill>
-                  <a:srgbClr val="1E293B"/>
-                </a:solidFill>
-                <a:latin typeface="Consolas"/>
-              </a:defRPr>
-            </a:pPr>
-            <a:r>
-              <a:t>    spark.read.jdbc(..., column='id', lowerBound=min_id,</a:t>
-            </a:r>
-          </a:p>
-          <a:p>
-            <a:pPr>
-              <a:defRPr sz="1600">
-                <a:solidFill>
-                  <a:srgbClr val="1E293B"/>
-                </a:solidFill>
-                <a:latin typeface="Consolas"/>
-              </a:defRPr>
-            </a:pPr>
-            <a:r>
-              <a:t>                    upperBound=max_id, numPartitions=optimal_partitions)</a:t>
-            </a:r>
-          </a:p>
-          <a:p>
-            <a:pPr>
-              <a:defRPr sz="1600">
-                <a:solidFill>
-                  <a:srgbClr val="1E293B"/>
-                </a:solidFill>
-                <a:latin typeface="Consolas"/>
-              </a:defRPr>
-            </a:pPr>
-            <a:r>
-              <a:t>else:</a:t>
-            </a:r>
-          </a:p>
-          <a:p>
-            <a:pPr>
-              <a:defRPr sz="1600">
-                <a:solidFill>
-                  <a:srgbClr val="1E293B"/>
-                </a:solidFill>
-                <a:latin typeface="Consolas"/>
-              </a:defRPr>
-            </a:pPr>
-            <a:r>
-              <a:t>    spark.read.jdbc(... single partition fallback ...)</a:t>
-            </a:r>
-          </a:p>
-        </p:txBody>
-      </p:sp>
-      <p:sp>
-        <p:nvSpPr>
-          <p:cNvPr id="4" name="TextBox 3"/>
-          <p:cNvSpPr txBox="1"/>
-          <p:nvPr/>
-        </p:nvSpPr>
-        <p:spPr>
-          <a:xfrm>
-            <a:off x="548640" y="6217920"/>
-            <a:ext cx="10972800" cy="457200"/>
-          </a:xfrm>
-          <a:prstGeom prst="rect">
-            <a:avLst/>
-          </a:prstGeom>
-          <a:noFill/>
-        </p:spPr>
-        <p:txBody>
-          <a:bodyPr wrap="none">
-            <a:spAutoFit/>
-          </a:bodyPr>
-          <a:lstStyle/>
-          <a:p>
-            <a:pPr>
-              <a:defRPr sz="1200">
-                <a:solidFill>
-                  <a:srgbClr val="475569"/>
-                </a:solidFill>
-              </a:defRPr>
-            </a:pPr>
-            <a:r>
-              <a:t>Why: prevents JDBC bottlenecks while avoiding excessive partition overhead.</a:t>
+              <a:t>Output artifacts stored in files/reports/*.json and *.csv</a:t>
             </a:r>
           </a:p>
         </p:txBody>
@@ -4420,174 +5388,55 @@
           <a:lstStyle/>
           <a:p>
             <a:r>
-              <a:rPr sz="3400">
-                <a:solidFill>
-                  <a:srgbClr val="0B2545"/>
-                </a:solidFill>
-              </a:rPr>
-              <a:t>Indicator Computation Core</a:t>
-            </a:r>
-          </a:p>
-        </p:txBody>
-      </p:sp>
-      <p:sp>
-        <p:nvSpPr>
-          <p:cNvPr id="3" name="TextBox 2"/>
-          <p:cNvSpPr txBox="1"/>
-          <p:nvPr/>
-        </p:nvSpPr>
-        <p:spPr>
-          <a:xfrm>
-            <a:off x="548640" y="1188720"/>
-            <a:ext cx="11064240" cy="4937760"/>
-          </a:xfrm>
-          <a:prstGeom prst="rect">
-            <a:avLst/>
-          </a:prstGeom>
-          <a:noFill/>
-        </p:spPr>
-        <p:txBody>
-          <a:bodyPr wrap="square">
-            <a:spAutoFit/>
-          </a:bodyPr>
+              <a:t>Email and Product Output</a:t>
+            </a:r>
+          </a:p>
+        </p:txBody>
+      </p:sp>
+      <p:sp>
+        <p:nvSpPr>
+          <p:cNvPr id="3" name="Content Placeholder 2"/>
+          <p:cNvSpPr>
+            <a:spLocks noGrp="1"/>
+          </p:cNvSpPr>
+          <p:nvPr>
+            <p:ph idx="1"/>
+          </p:nvPr>
+        </p:nvSpPr>
+        <p:spPr/>
+        <p:txBody>
+          <a:bodyPr/>
           <a:lstStyle/>
           <a:p>
             <a:pPr>
-              <a:defRPr sz="1600">
-                <a:solidFill>
-                  <a:srgbClr val="1E293B"/>
-                </a:solidFill>
-                <a:latin typeface="Consolas"/>
-              </a:defRPr>
+              <a:defRPr sz="1800"/>
             </a:pPr>
             <a:r>
-              <a:t>sma_50  = mean(close) over w_50</a:t>
+              <a:t>Workbook tabs per asset class keep only INVEST NOW/ACCUMULATE class candidates</a:t>
             </a:r>
           </a:p>
           <a:p>
             <a:pPr>
-              <a:defRPr sz="1600">
-                <a:solidFill>
-                  <a:srgbClr val="1E293B"/>
-                </a:solidFill>
-                <a:latin typeface="Consolas"/>
-              </a:defRPr>
+              <a:defRPr sz="2100"/>
             </a:pPr>
             <a:r>
-              <a:t>sma_200 = mean(close) over w_200</a:t>
+              <a:t>Confidence fields rendered as percentages</a:t>
             </a:r>
           </a:p>
           <a:p>
             <a:pPr>
-              <a:defRPr sz="1600">
-                <a:solidFill>
-                  <a:srgbClr val="1E293B"/>
-                </a:solidFill>
-                <a:latin typeface="Consolas"/>
-              </a:defRPr>
+              <a:defRPr sz="1800"/>
             </a:pPr>
             <a:r>
-              <a:t>moving_avg_7d = mean(close) over w_7</a:t>
+              <a:t>Validation Summary tab surfaces model health per asset class/horizon</a:t>
             </a:r>
           </a:p>
           <a:p>
             <a:pPr>
-              <a:defRPr sz="1600">
-                <a:solidFill>
-                  <a:srgbClr val="1E293B"/>
-                </a:solidFill>
-                <a:latin typeface="Consolas"/>
-              </a:defRPr>
+              <a:defRPr sz="1800"/>
             </a:pPr>
             <a:r>
-              <a:t>volatility_7d = stddev(close) over w_7</a:t>
-            </a:r>
-          </a:p>
-          <a:p>
-            <a:pPr>
-              <a:defRPr sz="1600">
-                <a:solidFill>
-                  <a:srgbClr val="1E293B"/>
-                </a:solidFill>
-                <a:latin typeface="Consolas"/>
-              </a:defRPr>
-            </a:pPr>
-            <a:r>
-              <a:t>ema_20 = mean(close) over w_20   # current approximation</a:t>
-            </a:r>
-          </a:p>
-          <a:p>
-            <a:pPr>
-              <a:defRPr sz="1600">
-                <a:solidFill>
-                  <a:srgbClr val="1E293B"/>
-                </a:solidFill>
-                <a:latin typeface="Consolas"/>
-              </a:defRPr>
-            </a:pPr>
-            <a:r>
-              <a:t>macd = mean(close) over w_12 - mean(close) over w_26</a:t>
-            </a:r>
-          </a:p>
-          <a:p>
-            <a:pPr>
-              <a:defRPr sz="1600">
-                <a:solidFill>
-                  <a:srgbClr val="1E293B"/>
-                </a:solidFill>
-                <a:latin typeface="Consolas"/>
-              </a:defRPr>
-            </a:pPr>
-            <a:r>
-              <a:t>bb_upper = sma_20 + 2*std_20</a:t>
-            </a:r>
-          </a:p>
-          <a:p>
-            <a:pPr>
-              <a:defRPr sz="1600">
-                <a:solidFill>
-                  <a:srgbClr val="1E293B"/>
-                </a:solidFill>
-                <a:latin typeface="Consolas"/>
-              </a:defRPr>
-            </a:pPr>
-            <a:r>
-              <a:t>bb_lower = sma_20 - 2*std_20</a:t>
-            </a:r>
-          </a:p>
-        </p:txBody>
-      </p:sp>
-      <p:sp>
-        <p:nvSpPr>
-          <p:cNvPr id="4" name="TextBox 3"/>
-          <p:cNvSpPr txBox="1"/>
-          <p:nvPr/>
-        </p:nvSpPr>
-        <p:spPr>
-          <a:xfrm>
-            <a:off x="548640" y="6217920"/>
-            <a:ext cx="10972800" cy="457200"/>
-          </a:xfrm>
-          <a:prstGeom prst="rect">
-            <a:avLst/>
-          </a:prstGeom>
-          <a:noFill/>
-        </p:spPr>
-        <p:txBody>
-          <a:bodyPr wrap="none">
-            <a:spAutoFit/>
-          </a:bodyPr>
-          <a:lstStyle/>
-          <a:p>
-            <a:pPr>
-              <a:defRPr sz="1200">
-                <a:solidFill>
-                  <a:srgbClr val="475569"/>
-                </a:solidFill>
-              </a:defRPr>
-            </a:pPr>
-            <a:r>
-              <a:t>All windows are partitioned by symbol and ordered by event_time.</a:t>
+              <a:t>Email body includes selected model, threshold, ROC-AUC, F1, and splits</a:t>
             </a:r>
           </a:p>
         </p:txBody>

</xml_diff>